<commit_message>
docs(deck): slide 4 now describes the confirmation step
The script said a member "can generate their own card" the moment they are
found, which stopped being true when the card moved behind a check. The
video for that slide will open on the confirmation panel, and the
narration would have been describing a screen that is no longer there.

It also reads better to a board: it lets the slide say that a person
always reviews a correction and that the website cannot write to the roll,
which are governance facts rather than features. 134 words, ~60 seconds.

The .pptx is rebuilt from the markdown, so the speaker notes carry the new
wording.

Co-Authored-By: Claude Opus 5 <noreply@anthropic.com>
</commit_message>
<xml_diff>
--- a/references/PMAFI-board-deck.pptx
+++ b/references/PMAFI-board-deck.pptx
@@ -842,55 +842,60 @@
           <a:lstStyle/>
           <a:p>
             <a:r>
-              <a:t>Once the site has found a member, they can generate their own identification</a:t>
-            </a:r>
-          </a:p>
-          <a:p>
-            <a:r>
-              <a:t>card, bearing the Foundation's seal.</a:t>
+              <a:t>Once the site has found a member, it shows them exactly what the card will</a:t>
+            </a:r>
+          </a:p>
+          <a:p>
+            <a:r>
+              <a:t>print — their name, membership category, PMA class and standing — and asks</a:t>
+            </a:r>
+          </a:p>
+          <a:p>
+            <a:r>
+              <a:t>them to confirm it before the card is made.</a:t>
             </a:r>
           </a:p>
           <a:p/>
           <a:p>
             <a:r>
-              <a:t>Their name, membership category, PMA class and standing all come from the</a:t>
-            </a:r>
-          </a:p>
-          <a:p>
-            <a:r>
-              <a:t>Foundation's own records and cannot be edited. The only thing the member</a:t>
-            </a:r>
-          </a:p>
-          <a:p>
-            <a:r>
-              <a:t>supplies is their photograph, and that photograph never leaves their own</a:t>
-            </a:r>
-          </a:p>
-          <a:p>
-            <a:r>
-              <a:t>device — it is never sent to us and never stored on a server.</a:t>
+              <a:t>If anything is wrong, they say so, and a correction request goes to the</a:t>
+            </a:r>
+          </a:p>
+          <a:p>
+            <a:r>
+              <a:t>Foundation. Staff check it and put the record right by hand. The website</a:t>
+            </a:r>
+          </a:p>
+          <a:p>
+            <a:r>
+              <a:t>cannot write to the roll, so a person always reviews the change.</a:t>
             </a:r>
           </a:p>
           <a:p/>
           <a:p>
             <a:r>
-              <a:t>The card states the member's standing as of the day it was generated. That</a:t>
-            </a:r>
-          </a:p>
-          <a:p>
-            <a:r>
-              <a:t>date is printed on purpose, so a card downloaded two years from now does not</a:t>
-            </a:r>
-          </a:p>
-          <a:p>
-            <a:r>
-              <a:t>go on asserting something that may since have changed.</a:t>
+              <a:t>If the details are right, the card is generated, bearing the Foundation's</a:t>
+            </a:r>
+          </a:p>
+          <a:p>
+            <a:r>
+              <a:t>seal. The only thing the member supplies is their photograph, and it never</a:t>
+            </a:r>
+          </a:p>
+          <a:p>
+            <a:r>
+              <a:t>leaves their own device — never sent to us, never stored on a server.</a:t>
             </a:r>
           </a:p>
           <a:p/>
           <a:p>
             <a:r>
-              <a:t>No visit to the office, and nothing to post.</a:t>
+              <a:t>The card states their standing as of the day it was made, so an old card does</a:t>
+            </a:r>
+          </a:p>
+          <a:p>
+            <a:r>
+              <a:t>not go on asserting something that may since have changed.</a:t>
             </a:r>
           </a:p>
         </p:txBody>

</xml_diff>